<commit_message>
Fix slide 5/7 elbow connectors; replace 'documents' with 'SOPs' throughout deck
- Slide 5: inherit-theme branch's elbow connector now ends at the right edge
  of the final 'theme catalog' node (was a straight vertical line ending in
  empty space below the inherit box).
- Slide 7: keep-concrete-only branch's elbow connector now ends at the
  final 'ordered backlog' node (same bug pattern as slide 5).
- Terminology: replace 'documents' / 'procedure documents' / 'document
  chunks' with 'SOPs' / 'SOP chunks' throughout the deck. The system
  handles only one document type — SOPs — so 'documents' was misleading.
  Slide 6 title: 'Phase 2 — Per-document processing' → 'Per-SOP processing'.

Co-Authored-By: Claude Opus 4.7 (1M context) <noreply@anthropic.com>
</commit_message>
<xml_diff>
--- a/client_alignment_deck.pptx
+++ b/client_alignment_deck.pptx
@@ -3203,7 +3203,7 @@
                 </a:solidFill>
                 <a:latin typeface="Calibri"/>
               </a:rPr>
-              <a:t>A system that turns lab procedure documents into a ready-to-use backlog of dev work — without an expert reviewing each item.</a:t>
+              <a:t>A system that turns SOPs (Standard Operating Procedures) into a ready-to-use backlog of dev work — without an expert reviewing each item.</a:t>
             </a:r>
           </a:p>
         </p:txBody>
@@ -3257,8 +3257,8 @@
                 </a:solidFill>
                 <a:latin typeface="Calibri"/>
               </a:rPr>
-              <a:t>Lab procedure documents
-(SOPs)</a:t>
+              <a:t>SOPs
+(Standard Operating Procedures)</a:t>
             </a:r>
           </a:p>
         </p:txBody>
@@ -3548,7 +3548,7 @@
                 </a:solidFill>
                 <a:latin typeface="Calibri"/>
               </a:rPr>
-              <a:t>•  Today: every new procedure → manual expert review → hand-written stories. Slow, costly, inconsistent.</a:t>
+              <a:t>•  Today: every new SOP → manual expert review → hand-written stories. Slow, costly, inconsistent.</a:t>
             </a:r>
           </a:p>
           <a:p>
@@ -3564,7 +3564,7 @@
                 </a:solidFill>
                 <a:latin typeface="Calibri"/>
               </a:rPr>
-              <a:t>•  With this system: documents in, structured stories out. Quality is built into the rules, not into one expert's review.</a:t>
+              <a:t>•  With this system: SOPs in, structured stories out. Quality is built into the rules, not into one expert's review.</a:t>
             </a:r>
           </a:p>
           <a:p>
@@ -4330,7 +4330,7 @@
                 </a:solidFill>
                 <a:latin typeface="Calibri"/>
               </a:rPr>
-              <a:t>Tests   •   Roles   •   Documents (new discipline's SOPs)   •   Tasks (out of scope; dev team owns decomposition)</a:t>
+              <a:t>Tests   •   Roles   •   The new discipline's own SOPs   •   Tasks (out of scope; dev team owns decomposition)</a:t>
             </a:r>
           </a:p>
         </p:txBody>
@@ -4792,7 +4792,7 @@
                           </a:solidFill>
                           <a:latin typeface="Calibri"/>
                         </a:rPr>
-                        <a:t>Builds the new discipline's theme catalog (categories) by classifying sample documents against the prior discipline's themes; new themes emerge only with evidence.</a:t>
+                        <a:t>Builds the new discipline's theme catalog (categories) by classifying sample SOPs against the prior discipline's themes; new themes emerge only with evidence.</a:t>
                       </a:r>
                     </a:p>
                   </a:txBody>
@@ -4887,7 +4887,7 @@
                           </a:solidFill>
                           <a:latin typeface="Calibri"/>
                         </a:rPr>
-                        <a:t>Drafts high-level epics from each document; matches each draft against the prior discipline's epic catalog. Matches inherit; non-matches are clustered for novelty review.</a:t>
+                        <a:t>Drafts high-level epics from each SOP; matches each draft against the prior discipline's epic catalog. Matches inherit; non-matches are clustered for novelty review.</a:t>
                       </a:r>
                     </a:p>
                   </a:txBody>
@@ -4910,7 +4910,7 @@
                           </a:solidFill>
                           <a:latin typeface="Calibri"/>
                         </a:rPr>
-                        <a:t>Once per document
+                        <a:t>Once per SOP
 + batch novelty pass</a:t>
                       </a:r>
                     </a:p>
@@ -4982,7 +4982,7 @@
                           </a:solidFill>
                           <a:latin typeface="Calibri"/>
                         </a:rPr>
-                        <a:t>Drafts user stories from document chunks using schema + shape definitions + closed-enum catalogs. Optionally retrieves (test, role, stage, shape)-matched exemplars from the prior discipline's Jira if it's available — improves style fidelity.</a:t>
+                        <a:t>Drafts user stories from SOP chunks using schema + shape definitions + closed-enum catalogs. Optionally retrieves (test, role, stage, shape)-matched exemplars from the prior discipline's Jira if it's available — improves style fidelity.</a:t>
                       </a:r>
                     </a:p>
                   </a:txBody>
@@ -5005,7 +5005,7 @@
                           </a:solidFill>
                           <a:latin typeface="Calibri"/>
                         </a:rPr>
-                        <a:t>Per epic, per document</a:t>
+                        <a:t>Per epic, per SOP</a:t>
                       </a:r>
                     </a:p>
                   </a:txBody>
@@ -5171,7 +5171,7 @@
                           </a:solidFill>
                           <a:latin typeface="Calibri"/>
                         </a:rPr>
-                        <a:t>After all documents are processed, finds patterns recurring across ≥ 2 documents and lifts them into broader "capability stories" with parameters.</a:t>
+                        <a:t>After all SOPs are processed, finds patterns recurring across ≥ 2 SOPs and lifts them into broader "capability stories" with parameters.</a:t>
                       </a:r>
                     </a:p>
                   </a:txBody>
@@ -5812,7 +5812,7 @@
                 <a:latin typeface="Calibri"/>
               </a:rPr>
               <a:t>Phase 2
-Per-document</a:t>
+Per-SOP</a:t>
             </a:r>
           </a:p>
         </p:txBody>
@@ -5847,7 +5847,7 @@
                 </a:solidFill>
                 <a:latin typeface="Calibri"/>
               </a:rPr>
-              <a:t>Read each procedure document, draft stories, quality-check.</a:t>
+              <a:t>Read each SOP, draft stories, quality-check.</a:t>
             </a:r>
           </a:p>
         </p:txBody>
@@ -5917,7 +5917,7 @@
                 </a:solidFill>
                 <a:latin typeface="Calibri"/>
               </a:rPr>
-              <a:t>Runs for every new procedure document.</a:t>
+              <a:t>Runs for every new SOP.</a:t>
             </a:r>
           </a:p>
         </p:txBody>
@@ -6007,7 +6007,7 @@
                 </a:solidFill>
                 <a:latin typeface="Calibri"/>
               </a:rPr>
-              <a:t>Look across all documents, lift recurring patterns, generate outputs.</a:t>
+              <a:t>Look across all SOPs, lift recurring patterns, generate outputs.</a:t>
             </a:r>
           </a:p>
         </p:txBody>
@@ -6077,7 +6077,7 @@
                 </a:solidFill>
                 <a:latin typeface="Calibri"/>
               </a:rPr>
-              <a:t>Runs after a batch of documents is processed.</a:t>
+              <a:t>Runs after a batch of SOPs is processed.</a:t>
             </a:r>
           </a:p>
         </p:txBody>
@@ -7469,9 +7469,9 @@
           <p:nvPr/>
         </p:nvCxnSpPr>
         <p:spPr>
-          <a:xfrm>
-            <a:off x="4709160" y="3543300"/>
-            <a:ext cx="0" cy="2468880"/>
+          <a:xfrm flipH="1">
+            <a:off x="3200400" y="3543300"/>
+            <a:ext cx="1508760" cy="2468880"/>
           </a:xfrm>
           <a:prstGeom prst="bentConnector3">
             <a:avLst/>
@@ -8267,7 +8267,7 @@
                 </a:solidFill>
                 <a:latin typeface="Calibri"/>
               </a:rPr>
-              <a:t>Phase 2 — Per-document processing</a:t>
+              <a:t>Phase 2 — Per-SOP processing</a:t>
             </a:r>
           </a:p>
         </p:txBody>
@@ -8345,7 +8345,7 @@
                 </a:solidFill>
                 <a:latin typeface="Calibri"/>
               </a:rPr>
-              <a:t>Runs once per procedure document. Result: validated stories under the right epics.</a:t>
+              <a:t>Runs once per SOP. Result: validated stories under the right epics.</a:t>
             </a:r>
           </a:p>
         </p:txBody>
@@ -9777,7 +9777,7 @@
                 </a:solidFill>
                 <a:latin typeface="Calibri"/>
               </a:rPr>
-              <a:t>Runs after a batch of documents. Recurring patterns lift to broader "capability stories" with parameters.</a:t>
+              <a:t>Runs after a batch of SOPs. Recurring patterns lift to broader "capability stories" with parameters.</a:t>
             </a:r>
           </a:p>
         </p:txBody>
@@ -9832,7 +9832,7 @@
                 <a:latin typeface="Calibri"/>
               </a:rPr>
               <a:t>All kept stories
-from all documents</a:t>
+from all SOPs</a:t>
             </a:r>
           </a:p>
         </p:txBody>
@@ -10549,9 +10549,9 @@
           <p:nvPr/>
         </p:nvCxnSpPr>
         <p:spPr>
-          <a:xfrm>
-            <a:off x="4709160" y="2994660"/>
-            <a:ext cx="0" cy="2194560"/>
+          <a:xfrm flipH="1">
+            <a:off x="3200400" y="2994660"/>
+            <a:ext cx="1508760" cy="2194560"/>
           </a:xfrm>
           <a:prstGeom prst="bentConnector3">
             <a:avLst/>
@@ -10986,7 +10986,7 @@
                 </a:solidFill>
                 <a:latin typeface="Consolas"/>
               </a:rPr>
-              <a:t>  source_documents: [SOP-014, SOP-019, SOP-022]</a:t>
+              <a:t>  source_sops: [SOP-014, SOP-019, SOP-022]</a:t>
             </a:r>
           </a:p>
         </p:txBody>
@@ -11701,7 +11701,7 @@
                 </a:solidFill>
                 <a:latin typeface="Calibri"/>
               </a:rPr>
-              <a:t>•  A sample of ~20 procedure documents per new discipline to seed Phase 1.</a:t>
+              <a:t>•  A sample of ~20 SOPs per new discipline to seed Phase 1.</a:t>
             </a:r>
           </a:p>
         </p:txBody>

</xml_diff>

<commit_message>
Slide 5: footnote clarifying single-label Pass 1 vs multi-label runtime tagging
Adds a small italic note below the bucket distribution: "Pass 1 here
is single-label — each chunk goes to its best-matching theme above
τ_match=0.65 (or to residual). Runtime story / chunk theme tags are
multi-label per D3 (themes are soft tags, not a forced taxonomy)."

Resolves a potential confusion source: the bucket arithmetic on slide 5
(477 inherited + 123 residual = 600 chunks, each in exactly one bucket)
implies single-label, while the substrate description on slide 6 and
D3 in the architecture doc note that runtime tagging is multi-label.
Both are correct — they apply at different points in the pipeline. The
footnote calls this out without restructuring the slide.

Co-Authored-By: Claude Opus 4.7 (1M context) <noreply@anthropic.com>
</commit_message>
<xml_diff>
--- a/client_alignment_deck.pptx
+++ b/client_alignment_deck.pptx
@@ -12806,7 +12806,42 @@
       </p:sp>
       <p:sp>
         <p:nvSpPr>
-          <p:cNvPr id="48" name="Rectangle 47"/>
+          <p:cNvPr id="48" name="TextBox 47"/>
+          <p:cNvSpPr txBox="1"/>
+          <p:nvPr/>
+        </p:nvSpPr>
+        <p:spPr>
+          <a:xfrm>
+            <a:off x="7040880" y="6062471"/>
+            <a:ext cx="4937760" cy="365760"/>
+          </a:xfrm>
+          <a:prstGeom prst="rect">
+            <a:avLst/>
+          </a:prstGeom>
+          <a:noFill/>
+        </p:spPr>
+        <p:txBody>
+          <a:bodyPr wrap="square" anchor="t">
+            <a:spAutoFit/>
+          </a:bodyPr>
+          <a:lstStyle/>
+          <a:p>
+            <a:pPr algn="l"/>
+            <a:r>
+              <a:rPr sz="800" b="0" i="1">
+                <a:solidFill>
+                  <a:srgbClr val="55606E"/>
+                </a:solidFill>
+                <a:latin typeface="Calibri"/>
+              </a:rPr>
+              <a:t>Note:  Pass 1 here is single-label — each chunk goes to its best-matching theme above τ_match=0.65 (or to residual). Runtime story / chunk theme tags are multi-label per D3 (themes are soft tags, not a forced taxonomy).</a:t>
+            </a:r>
+          </a:p>
+        </p:txBody>
+      </p:sp>
+      <p:sp>
+        <p:nvSpPr>
+          <p:cNvPr id="49" name="Rectangle 48"/>
           <p:cNvSpPr/>
           <p:nvPr/>
         </p:nvSpPr>
@@ -12849,7 +12884,7 @@
       </p:sp>
       <p:sp>
         <p:nvSpPr>
-          <p:cNvPr id="49" name="TextBox 48"/>
+          <p:cNvPr id="50" name="TextBox 49"/>
           <p:cNvSpPr txBox="1"/>
           <p:nvPr/>
         </p:nvSpPr>
@@ -12884,7 +12919,7 @@
       </p:sp>
       <p:sp>
         <p:nvSpPr>
-          <p:cNvPr id="50" name="TextBox 49"/>
+          <p:cNvPr id="51" name="TextBox 50"/>
           <p:cNvSpPr txBox="1"/>
           <p:nvPr/>
         </p:nvSpPr>

</xml_diff>